<commit_message>
feat(geometry): 补齐 ECMA-376 全部 187 个预设形状
原先 163 个，缺的 24 个走 `PRESETS[name] ?? PRESETS.rect` 静默画成矩形——
不报错、不进 unsupported，accentCallout* 这类常见形状出现即无声画错。

新增：accent/border/普通标注的第 3 段与重音变体（8 个）、bentUpArrow、
leftUpArrow、leftCircularArrow、leftRightCircularArrow、swooshArrow、
quadArrowCallout、upDownArrowCallout、ellipseRibbon(2)、leftRightRibbon、
cornerTabs、squareTabs、plaqueTabs、pieWedge、lineInv、flowChartOfflineStorage。

顺带修掉 borderCallout2 的既有 bug：3 点开放子路径会被 fill 补成实心楔形，
引线画成了黑三角。改走 seg() 零面积描线。

curvedArrow 加可选 both 参数长双箭头，both=false 时输出与改动前逐字节一致。

测试加 187 个规范名字的全覆盖闸门（挡住「静默退化成矩形」这类回归），
showcase 固件形状库从 120 增至 144，新形状进模糊测试名单。

Co-Authored-By: Claude Opus 5 <noreply@anthropic.com>
</commit_message>
<xml_diff>
--- a/fixtures/showcase.pptx
+++ b/fixtures/showcase.pptx
@@ -369,7 +369,7 @@
       </p:grpSpPr>
       <p:sp>
         <p:nvSpPr>
-          <p:cNvPr id="431" name="sp"/>
+          <p:cNvPr id="479" name="sp"/>
           <p:cNvSpPr/>
           <p:nvPr/>
         </p:nvSpPr>
@@ -488,7 +488,7 @@
       </p:grpSpPr>
       <p:sp>
         <p:nvSpPr>
-          <p:cNvPr id="341" name="sp"/>
+          <p:cNvPr id="389" name="sp"/>
           <p:cNvSpPr/>
           <p:nvPr/>
         </p:nvSpPr>
@@ -512,7 +512,7 @@
                   <a:schemeClr val="tx2"/>
                 </a:solidFill>
               </a:rPr>
-              <a:t>预设形状库（120 个）</a:t>
+              <a:t>预设形状库（144 个）</a:t>
             </a:r>
           </a:p>
         </p:txBody>
@@ -8073,6 +8073,1518 @@
                 </a:solidFill>
               </a:rPr>
               <a:t>gear9</a:t>
+            </a:r>
+          </a:p>
+        </p:txBody>
+      </p:sp>
+      <p:sp>
+        <p:nvSpPr>
+          <p:cNvPr id="341" name="bentUpArrow"/>
+          <p:cNvSpPr/>
+          <p:nvPr/>
+        </p:nvSpPr>
+        <p:spPr>
+          <a:xfrm>
+            <a:off x="6067425" y="4591050"/>
+            <a:ext cx="476250" cy="323850"/>
+          </a:xfrm>
+          <a:prstGeom prst="bentUpArrow">
+            <a:avLst/>
+          </a:prstGeom>
+          <a:solidFill>
+            <a:schemeClr val="accent1"/>
+          </a:solidFill>
+          <a:ln w="9525">
+            <a:solidFill>
+              <a:schemeClr val="tx2"/>
+            </a:solidFill>
+          </a:ln>
+        </p:spPr>
+        <p:txBody>
+          <a:bodyPr anchor="ctr"/>
+          <a:lstStyle/>
+          <a:p>
+            <a:endParaRPr/>
+          </a:p>
+        </p:txBody>
+      </p:sp>
+      <p:sp>
+        <p:nvSpPr>
+          <p:cNvPr id="342" name="sp"/>
+          <p:cNvSpPr/>
+          <p:nvPr/>
+        </p:nvSpPr>
+        <p:spPr>
+          <a:xfrm>
+            <a:off x="5943600" y="4924425"/>
+            <a:ext cx="723900" cy="133350"/>
+          </a:xfrm>
+          <a:prstGeom prst="rect">
+            <a:avLst/>
+          </a:prstGeom>
+          <a:noFill/>
+        </p:spPr>
+        <p:txBody>
+          <a:bodyPr anchor="ctr"/>
+          <a:lstStyle/>
+          <a:p>
+            <a:pPr algn="ctr"/>
+            <a:r>
+              <a:rPr sz="600">
+                <a:solidFill>
+                  <a:srgbClr val="666666"/>
+                </a:solidFill>
+              </a:rPr>
+              <a:t>bentUpArrow</a:t>
+            </a:r>
+          </a:p>
+        </p:txBody>
+      </p:sp>
+      <p:sp>
+        <p:nvSpPr>
+          <p:cNvPr id="343" name="leftUpArrow"/>
+          <p:cNvSpPr/>
+          <p:nvPr/>
+        </p:nvSpPr>
+        <p:spPr>
+          <a:xfrm>
+            <a:off x="6791325" y="4591050"/>
+            <a:ext cx="476250" cy="323850"/>
+          </a:xfrm>
+          <a:prstGeom prst="leftUpArrow">
+            <a:avLst/>
+          </a:prstGeom>
+          <a:solidFill>
+            <a:schemeClr val="accent2"/>
+          </a:solidFill>
+          <a:ln w="9525">
+            <a:solidFill>
+              <a:schemeClr val="tx2"/>
+            </a:solidFill>
+          </a:ln>
+        </p:spPr>
+        <p:txBody>
+          <a:bodyPr anchor="ctr"/>
+          <a:lstStyle/>
+          <a:p>
+            <a:endParaRPr/>
+          </a:p>
+        </p:txBody>
+      </p:sp>
+      <p:sp>
+        <p:nvSpPr>
+          <p:cNvPr id="344" name="sp"/>
+          <p:cNvSpPr/>
+          <p:nvPr/>
+        </p:nvSpPr>
+        <p:spPr>
+          <a:xfrm>
+            <a:off x="6667500" y="4924425"/>
+            <a:ext cx="723900" cy="133350"/>
+          </a:xfrm>
+          <a:prstGeom prst="rect">
+            <a:avLst/>
+          </a:prstGeom>
+          <a:noFill/>
+        </p:spPr>
+        <p:txBody>
+          <a:bodyPr anchor="ctr"/>
+          <a:lstStyle/>
+          <a:p>
+            <a:pPr algn="ctr"/>
+            <a:r>
+              <a:rPr sz="600">
+                <a:solidFill>
+                  <a:srgbClr val="666666"/>
+                </a:solidFill>
+              </a:rPr>
+              <a:t>leftUpArrow</a:t>
+            </a:r>
+          </a:p>
+        </p:txBody>
+      </p:sp>
+      <p:sp>
+        <p:nvSpPr>
+          <p:cNvPr id="345" name="leftCircularArrow"/>
+          <p:cNvSpPr/>
+          <p:nvPr/>
+        </p:nvSpPr>
+        <p:spPr>
+          <a:xfrm>
+            <a:off x="7515225" y="4591050"/>
+            <a:ext cx="476250" cy="323850"/>
+          </a:xfrm>
+          <a:prstGeom prst="leftCircularArrow">
+            <a:avLst/>
+          </a:prstGeom>
+          <a:solidFill>
+            <a:schemeClr val="accent3"/>
+          </a:solidFill>
+          <a:ln w="9525">
+            <a:solidFill>
+              <a:schemeClr val="tx2"/>
+            </a:solidFill>
+          </a:ln>
+        </p:spPr>
+        <p:txBody>
+          <a:bodyPr anchor="ctr"/>
+          <a:lstStyle/>
+          <a:p>
+            <a:endParaRPr/>
+          </a:p>
+        </p:txBody>
+      </p:sp>
+      <p:sp>
+        <p:nvSpPr>
+          <p:cNvPr id="346" name="sp"/>
+          <p:cNvSpPr/>
+          <p:nvPr/>
+        </p:nvSpPr>
+        <p:spPr>
+          <a:xfrm>
+            <a:off x="7391400" y="4924425"/>
+            <a:ext cx="723900" cy="133350"/>
+          </a:xfrm>
+          <a:prstGeom prst="rect">
+            <a:avLst/>
+          </a:prstGeom>
+          <a:noFill/>
+        </p:spPr>
+        <p:txBody>
+          <a:bodyPr anchor="ctr"/>
+          <a:lstStyle/>
+          <a:p>
+            <a:pPr algn="ctr"/>
+            <a:r>
+              <a:rPr sz="600">
+                <a:solidFill>
+                  <a:srgbClr val="666666"/>
+                </a:solidFill>
+              </a:rPr>
+              <a:t>leftCircularArrow</a:t>
+            </a:r>
+          </a:p>
+        </p:txBody>
+      </p:sp>
+      <p:sp>
+        <p:nvSpPr>
+          <p:cNvPr id="347" name="leftRightCircularArrow"/>
+          <p:cNvSpPr/>
+          <p:nvPr/>
+        </p:nvSpPr>
+        <p:spPr>
+          <a:xfrm>
+            <a:off x="8239125" y="4591050"/>
+            <a:ext cx="476250" cy="323850"/>
+          </a:xfrm>
+          <a:prstGeom prst="leftRightCircularArrow">
+            <a:avLst/>
+          </a:prstGeom>
+          <a:solidFill>
+            <a:schemeClr val="accent4"/>
+          </a:solidFill>
+          <a:ln w="9525">
+            <a:solidFill>
+              <a:schemeClr val="tx2"/>
+            </a:solidFill>
+          </a:ln>
+        </p:spPr>
+        <p:txBody>
+          <a:bodyPr anchor="ctr"/>
+          <a:lstStyle/>
+          <a:p>
+            <a:endParaRPr/>
+          </a:p>
+        </p:txBody>
+      </p:sp>
+      <p:sp>
+        <p:nvSpPr>
+          <p:cNvPr id="348" name="sp"/>
+          <p:cNvSpPr/>
+          <p:nvPr/>
+        </p:nvSpPr>
+        <p:spPr>
+          <a:xfrm>
+            <a:off x="8115300" y="4924425"/>
+            <a:ext cx="723900" cy="133350"/>
+          </a:xfrm>
+          <a:prstGeom prst="rect">
+            <a:avLst/>
+          </a:prstGeom>
+          <a:noFill/>
+        </p:spPr>
+        <p:txBody>
+          <a:bodyPr anchor="ctr"/>
+          <a:lstStyle/>
+          <a:p>
+            <a:pPr algn="ctr"/>
+            <a:r>
+              <a:rPr sz="600">
+                <a:solidFill>
+                  <a:srgbClr val="666666"/>
+                </a:solidFill>
+              </a:rPr>
+              <a:t>leftRightCircularArrow</a:t>
+            </a:r>
+          </a:p>
+        </p:txBody>
+      </p:sp>
+      <p:sp>
+        <p:nvSpPr>
+          <p:cNvPr id="349" name="swooshArrow"/>
+          <p:cNvSpPr/>
+          <p:nvPr/>
+        </p:nvSpPr>
+        <p:spPr>
+          <a:xfrm>
+            <a:off x="8963025" y="4591050"/>
+            <a:ext cx="476250" cy="323850"/>
+          </a:xfrm>
+          <a:prstGeom prst="swooshArrow">
+            <a:avLst/>
+          </a:prstGeom>
+          <a:solidFill>
+            <a:schemeClr val="accent5"/>
+          </a:solidFill>
+          <a:ln w="9525">
+            <a:solidFill>
+              <a:schemeClr val="tx2"/>
+            </a:solidFill>
+          </a:ln>
+        </p:spPr>
+        <p:txBody>
+          <a:bodyPr anchor="ctr"/>
+          <a:lstStyle/>
+          <a:p>
+            <a:endParaRPr/>
+          </a:p>
+        </p:txBody>
+      </p:sp>
+      <p:sp>
+        <p:nvSpPr>
+          <p:cNvPr id="350" name="sp"/>
+          <p:cNvSpPr/>
+          <p:nvPr/>
+        </p:nvSpPr>
+        <p:spPr>
+          <a:xfrm>
+            <a:off x="8839200" y="4924425"/>
+            <a:ext cx="723900" cy="133350"/>
+          </a:xfrm>
+          <a:prstGeom prst="rect">
+            <a:avLst/>
+          </a:prstGeom>
+          <a:noFill/>
+        </p:spPr>
+        <p:txBody>
+          <a:bodyPr anchor="ctr"/>
+          <a:lstStyle/>
+          <a:p>
+            <a:pPr algn="ctr"/>
+            <a:r>
+              <a:rPr sz="600">
+                <a:solidFill>
+                  <a:srgbClr val="666666"/>
+                </a:solidFill>
+              </a:rPr>
+              <a:t>swooshArrow</a:t>
+            </a:r>
+          </a:p>
+        </p:txBody>
+      </p:sp>
+      <p:sp>
+        <p:nvSpPr>
+          <p:cNvPr id="351" name="quadArrowCallout"/>
+          <p:cNvSpPr/>
+          <p:nvPr/>
+        </p:nvSpPr>
+        <p:spPr>
+          <a:xfrm>
+            <a:off x="9686925" y="4591050"/>
+            <a:ext cx="476250" cy="323850"/>
+          </a:xfrm>
+          <a:prstGeom prst="quadArrowCallout">
+            <a:avLst/>
+          </a:prstGeom>
+          <a:solidFill>
+            <a:schemeClr val="accent6"/>
+          </a:solidFill>
+          <a:ln w="9525">
+            <a:solidFill>
+              <a:schemeClr val="tx2"/>
+            </a:solidFill>
+          </a:ln>
+        </p:spPr>
+        <p:txBody>
+          <a:bodyPr anchor="ctr"/>
+          <a:lstStyle/>
+          <a:p>
+            <a:endParaRPr/>
+          </a:p>
+        </p:txBody>
+      </p:sp>
+      <p:sp>
+        <p:nvSpPr>
+          <p:cNvPr id="352" name="sp"/>
+          <p:cNvSpPr/>
+          <p:nvPr/>
+        </p:nvSpPr>
+        <p:spPr>
+          <a:xfrm>
+            <a:off x="9563100" y="4924425"/>
+            <a:ext cx="723900" cy="133350"/>
+          </a:xfrm>
+          <a:prstGeom prst="rect">
+            <a:avLst/>
+          </a:prstGeom>
+          <a:noFill/>
+        </p:spPr>
+        <p:txBody>
+          <a:bodyPr anchor="ctr"/>
+          <a:lstStyle/>
+          <a:p>
+            <a:pPr algn="ctr"/>
+            <a:r>
+              <a:rPr sz="600">
+                <a:solidFill>
+                  <a:srgbClr val="666666"/>
+                </a:solidFill>
+              </a:rPr>
+              <a:t>quadArrowCallout</a:t>
+            </a:r>
+          </a:p>
+        </p:txBody>
+      </p:sp>
+      <p:sp>
+        <p:nvSpPr>
+          <p:cNvPr id="353" name="upDownArrowCallout"/>
+          <p:cNvSpPr/>
+          <p:nvPr/>
+        </p:nvSpPr>
+        <p:spPr>
+          <a:xfrm>
+            <a:off x="10410825" y="4591050"/>
+            <a:ext cx="476250" cy="323850"/>
+          </a:xfrm>
+          <a:prstGeom prst="upDownArrowCallout">
+            <a:avLst/>
+          </a:prstGeom>
+          <a:solidFill>
+            <a:schemeClr val="accent1"/>
+          </a:solidFill>
+          <a:ln w="9525">
+            <a:solidFill>
+              <a:schemeClr val="tx2"/>
+            </a:solidFill>
+          </a:ln>
+        </p:spPr>
+        <p:txBody>
+          <a:bodyPr anchor="ctr"/>
+          <a:lstStyle/>
+          <a:p>
+            <a:endParaRPr/>
+          </a:p>
+        </p:txBody>
+      </p:sp>
+      <p:sp>
+        <p:nvSpPr>
+          <p:cNvPr id="354" name="sp"/>
+          <p:cNvSpPr/>
+          <p:nvPr/>
+        </p:nvSpPr>
+        <p:spPr>
+          <a:xfrm>
+            <a:off x="10287000" y="4924425"/>
+            <a:ext cx="723900" cy="133350"/>
+          </a:xfrm>
+          <a:prstGeom prst="rect">
+            <a:avLst/>
+          </a:prstGeom>
+          <a:noFill/>
+        </p:spPr>
+        <p:txBody>
+          <a:bodyPr anchor="ctr"/>
+          <a:lstStyle/>
+          <a:p>
+            <a:pPr algn="ctr"/>
+            <a:r>
+              <a:rPr sz="600">
+                <a:solidFill>
+                  <a:srgbClr val="666666"/>
+                </a:solidFill>
+              </a:rPr>
+              <a:t>upDownArrowCallout</a:t>
+            </a:r>
+          </a:p>
+        </p:txBody>
+      </p:sp>
+      <p:sp>
+        <p:nvSpPr>
+          <p:cNvPr id="355" name="pieWedge"/>
+          <p:cNvSpPr/>
+          <p:nvPr/>
+        </p:nvSpPr>
+        <p:spPr>
+          <a:xfrm>
+            <a:off x="11134725" y="4591050"/>
+            <a:ext cx="476250" cy="323850"/>
+          </a:xfrm>
+          <a:prstGeom prst="pieWedge">
+            <a:avLst/>
+          </a:prstGeom>
+          <a:solidFill>
+            <a:schemeClr val="accent2"/>
+          </a:solidFill>
+          <a:ln w="9525">
+            <a:solidFill>
+              <a:schemeClr val="tx2"/>
+            </a:solidFill>
+          </a:ln>
+        </p:spPr>
+        <p:txBody>
+          <a:bodyPr anchor="ctr"/>
+          <a:lstStyle/>
+          <a:p>
+            <a:endParaRPr/>
+          </a:p>
+        </p:txBody>
+      </p:sp>
+      <p:sp>
+        <p:nvSpPr>
+          <p:cNvPr id="356" name="sp"/>
+          <p:cNvSpPr/>
+          <p:nvPr/>
+        </p:nvSpPr>
+        <p:spPr>
+          <a:xfrm>
+            <a:off x="11010900" y="4924425"/>
+            <a:ext cx="723900" cy="133350"/>
+          </a:xfrm>
+          <a:prstGeom prst="rect">
+            <a:avLst/>
+          </a:prstGeom>
+          <a:noFill/>
+        </p:spPr>
+        <p:txBody>
+          <a:bodyPr anchor="ctr"/>
+          <a:lstStyle/>
+          <a:p>
+            <a:pPr algn="ctr"/>
+            <a:r>
+              <a:rPr sz="600">
+                <a:solidFill>
+                  <a:srgbClr val="666666"/>
+                </a:solidFill>
+              </a:rPr>
+              <a:t>pieWedge</a:t>
+            </a:r>
+          </a:p>
+        </p:txBody>
+      </p:sp>
+      <p:sp>
+        <p:nvSpPr>
+          <p:cNvPr id="357" name="ellipseRibbon"/>
+          <p:cNvSpPr/>
+          <p:nvPr/>
+        </p:nvSpPr>
+        <p:spPr>
+          <a:xfrm>
+            <a:off x="276225" y="5181600"/>
+            <a:ext cx="476250" cy="323850"/>
+          </a:xfrm>
+          <a:prstGeom prst="ellipseRibbon">
+            <a:avLst/>
+          </a:prstGeom>
+          <a:solidFill>
+            <a:schemeClr val="accent3"/>
+          </a:solidFill>
+          <a:ln w="9525">
+            <a:solidFill>
+              <a:schemeClr val="tx2"/>
+            </a:solidFill>
+          </a:ln>
+        </p:spPr>
+        <p:txBody>
+          <a:bodyPr anchor="ctr"/>
+          <a:lstStyle/>
+          <a:p>
+            <a:endParaRPr/>
+          </a:p>
+        </p:txBody>
+      </p:sp>
+      <p:sp>
+        <p:nvSpPr>
+          <p:cNvPr id="358" name="sp"/>
+          <p:cNvSpPr/>
+          <p:nvPr/>
+        </p:nvSpPr>
+        <p:spPr>
+          <a:xfrm>
+            <a:off x="152400" y="5514975"/>
+            <a:ext cx="723900" cy="133350"/>
+          </a:xfrm>
+          <a:prstGeom prst="rect">
+            <a:avLst/>
+          </a:prstGeom>
+          <a:noFill/>
+        </p:spPr>
+        <p:txBody>
+          <a:bodyPr anchor="ctr"/>
+          <a:lstStyle/>
+          <a:p>
+            <a:pPr algn="ctr"/>
+            <a:r>
+              <a:rPr sz="600">
+                <a:solidFill>
+                  <a:srgbClr val="666666"/>
+                </a:solidFill>
+              </a:rPr>
+              <a:t>ellipseRibbon</a:t>
+            </a:r>
+          </a:p>
+        </p:txBody>
+      </p:sp>
+      <p:sp>
+        <p:nvSpPr>
+          <p:cNvPr id="359" name="ellipseRibbon2"/>
+          <p:cNvSpPr/>
+          <p:nvPr/>
+        </p:nvSpPr>
+        <p:spPr>
+          <a:xfrm>
+            <a:off x="1000125" y="5181600"/>
+            <a:ext cx="476250" cy="323850"/>
+          </a:xfrm>
+          <a:prstGeom prst="ellipseRibbon2">
+            <a:avLst/>
+          </a:prstGeom>
+          <a:solidFill>
+            <a:schemeClr val="accent4"/>
+          </a:solidFill>
+          <a:ln w="9525">
+            <a:solidFill>
+              <a:schemeClr val="tx2"/>
+            </a:solidFill>
+          </a:ln>
+        </p:spPr>
+        <p:txBody>
+          <a:bodyPr anchor="ctr"/>
+          <a:lstStyle/>
+          <a:p>
+            <a:endParaRPr/>
+          </a:p>
+        </p:txBody>
+      </p:sp>
+      <p:sp>
+        <p:nvSpPr>
+          <p:cNvPr id="360" name="sp"/>
+          <p:cNvSpPr/>
+          <p:nvPr/>
+        </p:nvSpPr>
+        <p:spPr>
+          <a:xfrm>
+            <a:off x="876300" y="5514975"/>
+            <a:ext cx="723900" cy="133350"/>
+          </a:xfrm>
+          <a:prstGeom prst="rect">
+            <a:avLst/>
+          </a:prstGeom>
+          <a:noFill/>
+        </p:spPr>
+        <p:txBody>
+          <a:bodyPr anchor="ctr"/>
+          <a:lstStyle/>
+          <a:p>
+            <a:pPr algn="ctr"/>
+            <a:r>
+              <a:rPr sz="600">
+                <a:solidFill>
+                  <a:srgbClr val="666666"/>
+                </a:solidFill>
+              </a:rPr>
+              <a:t>ellipseRibbon2</a:t>
+            </a:r>
+          </a:p>
+        </p:txBody>
+      </p:sp>
+      <p:sp>
+        <p:nvSpPr>
+          <p:cNvPr id="361" name="leftRightRibbon"/>
+          <p:cNvSpPr/>
+          <p:nvPr/>
+        </p:nvSpPr>
+        <p:spPr>
+          <a:xfrm>
+            <a:off x="1724025" y="5181600"/>
+            <a:ext cx="476250" cy="323850"/>
+          </a:xfrm>
+          <a:prstGeom prst="leftRightRibbon">
+            <a:avLst/>
+          </a:prstGeom>
+          <a:solidFill>
+            <a:schemeClr val="accent5"/>
+          </a:solidFill>
+          <a:ln w="9525">
+            <a:solidFill>
+              <a:schemeClr val="tx2"/>
+            </a:solidFill>
+          </a:ln>
+        </p:spPr>
+        <p:txBody>
+          <a:bodyPr anchor="ctr"/>
+          <a:lstStyle/>
+          <a:p>
+            <a:endParaRPr/>
+          </a:p>
+        </p:txBody>
+      </p:sp>
+      <p:sp>
+        <p:nvSpPr>
+          <p:cNvPr id="362" name="sp"/>
+          <p:cNvSpPr/>
+          <p:nvPr/>
+        </p:nvSpPr>
+        <p:spPr>
+          <a:xfrm>
+            <a:off x="1600200" y="5514975"/>
+            <a:ext cx="723900" cy="133350"/>
+          </a:xfrm>
+          <a:prstGeom prst="rect">
+            <a:avLst/>
+          </a:prstGeom>
+          <a:noFill/>
+        </p:spPr>
+        <p:txBody>
+          <a:bodyPr anchor="ctr"/>
+          <a:lstStyle/>
+          <a:p>
+            <a:pPr algn="ctr"/>
+            <a:r>
+              <a:rPr sz="600">
+                <a:solidFill>
+                  <a:srgbClr val="666666"/>
+                </a:solidFill>
+              </a:rPr>
+              <a:t>leftRightRibbon</a:t>
+            </a:r>
+          </a:p>
+        </p:txBody>
+      </p:sp>
+      <p:sp>
+        <p:nvSpPr>
+          <p:cNvPr id="363" name="cornerTabs"/>
+          <p:cNvSpPr/>
+          <p:nvPr/>
+        </p:nvSpPr>
+        <p:spPr>
+          <a:xfrm>
+            <a:off x="2447925" y="5181600"/>
+            <a:ext cx="476250" cy="323850"/>
+          </a:xfrm>
+          <a:prstGeom prst="cornerTabs">
+            <a:avLst/>
+          </a:prstGeom>
+          <a:solidFill>
+            <a:schemeClr val="accent6"/>
+          </a:solidFill>
+          <a:ln w="9525">
+            <a:solidFill>
+              <a:schemeClr val="tx2"/>
+            </a:solidFill>
+          </a:ln>
+        </p:spPr>
+        <p:txBody>
+          <a:bodyPr anchor="ctr"/>
+          <a:lstStyle/>
+          <a:p>
+            <a:endParaRPr/>
+          </a:p>
+        </p:txBody>
+      </p:sp>
+      <p:sp>
+        <p:nvSpPr>
+          <p:cNvPr id="364" name="sp"/>
+          <p:cNvSpPr/>
+          <p:nvPr/>
+        </p:nvSpPr>
+        <p:spPr>
+          <a:xfrm>
+            <a:off x="2324100" y="5514975"/>
+            <a:ext cx="723900" cy="133350"/>
+          </a:xfrm>
+          <a:prstGeom prst="rect">
+            <a:avLst/>
+          </a:prstGeom>
+          <a:noFill/>
+        </p:spPr>
+        <p:txBody>
+          <a:bodyPr anchor="ctr"/>
+          <a:lstStyle/>
+          <a:p>
+            <a:pPr algn="ctr"/>
+            <a:r>
+              <a:rPr sz="600">
+                <a:solidFill>
+                  <a:srgbClr val="666666"/>
+                </a:solidFill>
+              </a:rPr>
+              <a:t>cornerTabs</a:t>
+            </a:r>
+          </a:p>
+        </p:txBody>
+      </p:sp>
+      <p:sp>
+        <p:nvSpPr>
+          <p:cNvPr id="365" name="squareTabs"/>
+          <p:cNvSpPr/>
+          <p:nvPr/>
+        </p:nvSpPr>
+        <p:spPr>
+          <a:xfrm>
+            <a:off x="3171825" y="5181600"/>
+            <a:ext cx="476250" cy="323850"/>
+          </a:xfrm>
+          <a:prstGeom prst="squareTabs">
+            <a:avLst/>
+          </a:prstGeom>
+          <a:solidFill>
+            <a:schemeClr val="accent1"/>
+          </a:solidFill>
+          <a:ln w="9525">
+            <a:solidFill>
+              <a:schemeClr val="tx2"/>
+            </a:solidFill>
+          </a:ln>
+        </p:spPr>
+        <p:txBody>
+          <a:bodyPr anchor="ctr"/>
+          <a:lstStyle/>
+          <a:p>
+            <a:endParaRPr/>
+          </a:p>
+        </p:txBody>
+      </p:sp>
+      <p:sp>
+        <p:nvSpPr>
+          <p:cNvPr id="366" name="sp"/>
+          <p:cNvSpPr/>
+          <p:nvPr/>
+        </p:nvSpPr>
+        <p:spPr>
+          <a:xfrm>
+            <a:off x="3048000" y="5514975"/>
+            <a:ext cx="723900" cy="133350"/>
+          </a:xfrm>
+          <a:prstGeom prst="rect">
+            <a:avLst/>
+          </a:prstGeom>
+          <a:noFill/>
+        </p:spPr>
+        <p:txBody>
+          <a:bodyPr anchor="ctr"/>
+          <a:lstStyle/>
+          <a:p>
+            <a:pPr algn="ctr"/>
+            <a:r>
+              <a:rPr sz="600">
+                <a:solidFill>
+                  <a:srgbClr val="666666"/>
+                </a:solidFill>
+              </a:rPr>
+              <a:t>squareTabs</a:t>
+            </a:r>
+          </a:p>
+        </p:txBody>
+      </p:sp>
+      <p:sp>
+        <p:nvSpPr>
+          <p:cNvPr id="367" name="plaqueTabs"/>
+          <p:cNvSpPr/>
+          <p:nvPr/>
+        </p:nvSpPr>
+        <p:spPr>
+          <a:xfrm>
+            <a:off x="3895725" y="5181600"/>
+            <a:ext cx="476250" cy="323850"/>
+          </a:xfrm>
+          <a:prstGeom prst="plaqueTabs">
+            <a:avLst/>
+          </a:prstGeom>
+          <a:solidFill>
+            <a:schemeClr val="accent2"/>
+          </a:solidFill>
+          <a:ln w="9525">
+            <a:solidFill>
+              <a:schemeClr val="tx2"/>
+            </a:solidFill>
+          </a:ln>
+        </p:spPr>
+        <p:txBody>
+          <a:bodyPr anchor="ctr"/>
+          <a:lstStyle/>
+          <a:p>
+            <a:endParaRPr/>
+          </a:p>
+        </p:txBody>
+      </p:sp>
+      <p:sp>
+        <p:nvSpPr>
+          <p:cNvPr id="368" name="sp"/>
+          <p:cNvSpPr/>
+          <p:nvPr/>
+        </p:nvSpPr>
+        <p:spPr>
+          <a:xfrm>
+            <a:off x="3771900" y="5514975"/>
+            <a:ext cx="723900" cy="133350"/>
+          </a:xfrm>
+          <a:prstGeom prst="rect">
+            <a:avLst/>
+          </a:prstGeom>
+          <a:noFill/>
+        </p:spPr>
+        <p:txBody>
+          <a:bodyPr anchor="ctr"/>
+          <a:lstStyle/>
+          <a:p>
+            <a:pPr algn="ctr"/>
+            <a:r>
+              <a:rPr sz="600">
+                <a:solidFill>
+                  <a:srgbClr val="666666"/>
+                </a:solidFill>
+              </a:rPr>
+              <a:t>plaqueTabs</a:t>
+            </a:r>
+          </a:p>
+        </p:txBody>
+      </p:sp>
+      <p:sp>
+        <p:nvSpPr>
+          <p:cNvPr id="369" name="lineInv"/>
+          <p:cNvSpPr/>
+          <p:nvPr/>
+        </p:nvSpPr>
+        <p:spPr>
+          <a:xfrm>
+            <a:off x="4619625" y="5181600"/>
+            <a:ext cx="476250" cy="323850"/>
+          </a:xfrm>
+          <a:prstGeom prst="lineInv">
+            <a:avLst/>
+          </a:prstGeom>
+          <a:solidFill>
+            <a:schemeClr val="accent3"/>
+          </a:solidFill>
+          <a:ln w="9525">
+            <a:solidFill>
+              <a:schemeClr val="tx2"/>
+            </a:solidFill>
+          </a:ln>
+        </p:spPr>
+        <p:txBody>
+          <a:bodyPr anchor="ctr"/>
+          <a:lstStyle/>
+          <a:p>
+            <a:endParaRPr/>
+          </a:p>
+        </p:txBody>
+      </p:sp>
+      <p:sp>
+        <p:nvSpPr>
+          <p:cNvPr id="370" name="sp"/>
+          <p:cNvSpPr/>
+          <p:nvPr/>
+        </p:nvSpPr>
+        <p:spPr>
+          <a:xfrm>
+            <a:off x="4495800" y="5514975"/>
+            <a:ext cx="723900" cy="133350"/>
+          </a:xfrm>
+          <a:prstGeom prst="rect">
+            <a:avLst/>
+          </a:prstGeom>
+          <a:noFill/>
+        </p:spPr>
+        <p:txBody>
+          <a:bodyPr anchor="ctr"/>
+          <a:lstStyle/>
+          <a:p>
+            <a:pPr algn="ctr"/>
+            <a:r>
+              <a:rPr sz="600">
+                <a:solidFill>
+                  <a:srgbClr val="666666"/>
+                </a:solidFill>
+              </a:rPr>
+              <a:t>lineInv</a:t>
+            </a:r>
+          </a:p>
+        </p:txBody>
+      </p:sp>
+      <p:sp>
+        <p:nvSpPr>
+          <p:cNvPr id="371" name="flowChartOfflineStorage"/>
+          <p:cNvSpPr/>
+          <p:nvPr/>
+        </p:nvSpPr>
+        <p:spPr>
+          <a:xfrm>
+            <a:off x="5343525" y="5181600"/>
+            <a:ext cx="476250" cy="323850"/>
+          </a:xfrm>
+          <a:prstGeom prst="flowChartOfflineStorage">
+            <a:avLst/>
+          </a:prstGeom>
+          <a:solidFill>
+            <a:schemeClr val="accent4"/>
+          </a:solidFill>
+          <a:ln w="9525">
+            <a:solidFill>
+              <a:schemeClr val="tx2"/>
+            </a:solidFill>
+          </a:ln>
+        </p:spPr>
+        <p:txBody>
+          <a:bodyPr anchor="ctr"/>
+          <a:lstStyle/>
+          <a:p>
+            <a:endParaRPr/>
+          </a:p>
+        </p:txBody>
+      </p:sp>
+      <p:sp>
+        <p:nvSpPr>
+          <p:cNvPr id="372" name="sp"/>
+          <p:cNvSpPr/>
+          <p:nvPr/>
+        </p:nvSpPr>
+        <p:spPr>
+          <a:xfrm>
+            <a:off x="5219700" y="5514975"/>
+            <a:ext cx="723900" cy="133350"/>
+          </a:xfrm>
+          <a:prstGeom prst="rect">
+            <a:avLst/>
+          </a:prstGeom>
+          <a:noFill/>
+        </p:spPr>
+        <p:txBody>
+          <a:bodyPr anchor="ctr"/>
+          <a:lstStyle/>
+          <a:p>
+            <a:pPr algn="ctr"/>
+            <a:r>
+              <a:rPr sz="600">
+                <a:solidFill>
+                  <a:srgbClr val="666666"/>
+                </a:solidFill>
+              </a:rPr>
+              <a:t>OfflineStorage</a:t>
+            </a:r>
+          </a:p>
+        </p:txBody>
+      </p:sp>
+      <p:sp>
+        <p:nvSpPr>
+          <p:cNvPr id="373" name="callout3"/>
+          <p:cNvSpPr/>
+          <p:nvPr/>
+        </p:nvSpPr>
+        <p:spPr>
+          <a:xfrm>
+            <a:off x="6067425" y="5181600"/>
+            <a:ext cx="476250" cy="323850"/>
+          </a:xfrm>
+          <a:prstGeom prst="callout3">
+            <a:avLst/>
+          </a:prstGeom>
+          <a:solidFill>
+            <a:schemeClr val="accent5"/>
+          </a:solidFill>
+          <a:ln w="9525">
+            <a:solidFill>
+              <a:schemeClr val="tx2"/>
+            </a:solidFill>
+          </a:ln>
+        </p:spPr>
+        <p:txBody>
+          <a:bodyPr anchor="ctr"/>
+          <a:lstStyle/>
+          <a:p>
+            <a:endParaRPr/>
+          </a:p>
+        </p:txBody>
+      </p:sp>
+      <p:sp>
+        <p:nvSpPr>
+          <p:cNvPr id="374" name="sp"/>
+          <p:cNvSpPr/>
+          <p:nvPr/>
+        </p:nvSpPr>
+        <p:spPr>
+          <a:xfrm>
+            <a:off x="5943600" y="5514975"/>
+            <a:ext cx="723900" cy="133350"/>
+          </a:xfrm>
+          <a:prstGeom prst="rect">
+            <a:avLst/>
+          </a:prstGeom>
+          <a:noFill/>
+        </p:spPr>
+        <p:txBody>
+          <a:bodyPr anchor="ctr"/>
+          <a:lstStyle/>
+          <a:p>
+            <a:pPr algn="ctr"/>
+            <a:r>
+              <a:rPr sz="600">
+                <a:solidFill>
+                  <a:srgbClr val="666666"/>
+                </a:solidFill>
+              </a:rPr>
+              <a:t>callout3</a:t>
+            </a:r>
+          </a:p>
+        </p:txBody>
+      </p:sp>
+      <p:sp>
+        <p:nvSpPr>
+          <p:cNvPr id="375" name="borderCallout3"/>
+          <p:cNvSpPr/>
+          <p:nvPr/>
+        </p:nvSpPr>
+        <p:spPr>
+          <a:xfrm>
+            <a:off x="6791325" y="5181600"/>
+            <a:ext cx="476250" cy="323850"/>
+          </a:xfrm>
+          <a:prstGeom prst="borderCallout3">
+            <a:avLst/>
+          </a:prstGeom>
+          <a:solidFill>
+            <a:schemeClr val="accent6"/>
+          </a:solidFill>
+          <a:ln w="9525">
+            <a:solidFill>
+              <a:schemeClr val="tx2"/>
+            </a:solidFill>
+          </a:ln>
+        </p:spPr>
+        <p:txBody>
+          <a:bodyPr anchor="ctr"/>
+          <a:lstStyle/>
+          <a:p>
+            <a:endParaRPr/>
+          </a:p>
+        </p:txBody>
+      </p:sp>
+      <p:sp>
+        <p:nvSpPr>
+          <p:cNvPr id="376" name="sp"/>
+          <p:cNvSpPr/>
+          <p:nvPr/>
+        </p:nvSpPr>
+        <p:spPr>
+          <a:xfrm>
+            <a:off x="6667500" y="5514975"/>
+            <a:ext cx="723900" cy="133350"/>
+          </a:xfrm>
+          <a:prstGeom prst="rect">
+            <a:avLst/>
+          </a:prstGeom>
+          <a:noFill/>
+        </p:spPr>
+        <p:txBody>
+          <a:bodyPr anchor="ctr"/>
+          <a:lstStyle/>
+          <a:p>
+            <a:pPr algn="ctr"/>
+            <a:r>
+              <a:rPr sz="600">
+                <a:solidFill>
+                  <a:srgbClr val="666666"/>
+                </a:solidFill>
+              </a:rPr>
+              <a:t>borderCallout3</a:t>
+            </a:r>
+          </a:p>
+        </p:txBody>
+      </p:sp>
+      <p:sp>
+        <p:nvSpPr>
+          <p:cNvPr id="377" name="accentCallout1"/>
+          <p:cNvSpPr/>
+          <p:nvPr/>
+        </p:nvSpPr>
+        <p:spPr>
+          <a:xfrm>
+            <a:off x="7515225" y="5181600"/>
+            <a:ext cx="476250" cy="323850"/>
+          </a:xfrm>
+          <a:prstGeom prst="accentCallout1">
+            <a:avLst/>
+          </a:prstGeom>
+          <a:solidFill>
+            <a:schemeClr val="accent1"/>
+          </a:solidFill>
+          <a:ln w="9525">
+            <a:solidFill>
+              <a:schemeClr val="tx2"/>
+            </a:solidFill>
+          </a:ln>
+        </p:spPr>
+        <p:txBody>
+          <a:bodyPr anchor="ctr"/>
+          <a:lstStyle/>
+          <a:p>
+            <a:endParaRPr/>
+          </a:p>
+        </p:txBody>
+      </p:sp>
+      <p:sp>
+        <p:nvSpPr>
+          <p:cNvPr id="378" name="sp"/>
+          <p:cNvSpPr/>
+          <p:nvPr/>
+        </p:nvSpPr>
+        <p:spPr>
+          <a:xfrm>
+            <a:off x="7391400" y="5514975"/>
+            <a:ext cx="723900" cy="133350"/>
+          </a:xfrm>
+          <a:prstGeom prst="rect">
+            <a:avLst/>
+          </a:prstGeom>
+          <a:noFill/>
+        </p:spPr>
+        <p:txBody>
+          <a:bodyPr anchor="ctr"/>
+          <a:lstStyle/>
+          <a:p>
+            <a:pPr algn="ctr"/>
+            <a:r>
+              <a:rPr sz="600">
+                <a:solidFill>
+                  <a:srgbClr val="666666"/>
+                </a:solidFill>
+              </a:rPr>
+              <a:t>accentCallout1</a:t>
+            </a:r>
+          </a:p>
+        </p:txBody>
+      </p:sp>
+      <p:sp>
+        <p:nvSpPr>
+          <p:cNvPr id="379" name="accentCallout2"/>
+          <p:cNvSpPr/>
+          <p:nvPr/>
+        </p:nvSpPr>
+        <p:spPr>
+          <a:xfrm>
+            <a:off x="8239125" y="5181600"/>
+            <a:ext cx="476250" cy="323850"/>
+          </a:xfrm>
+          <a:prstGeom prst="accentCallout2">
+            <a:avLst/>
+          </a:prstGeom>
+          <a:solidFill>
+            <a:schemeClr val="accent2"/>
+          </a:solidFill>
+          <a:ln w="9525">
+            <a:solidFill>
+              <a:schemeClr val="tx2"/>
+            </a:solidFill>
+          </a:ln>
+        </p:spPr>
+        <p:txBody>
+          <a:bodyPr anchor="ctr"/>
+          <a:lstStyle/>
+          <a:p>
+            <a:endParaRPr/>
+          </a:p>
+        </p:txBody>
+      </p:sp>
+      <p:sp>
+        <p:nvSpPr>
+          <p:cNvPr id="380" name="sp"/>
+          <p:cNvSpPr/>
+          <p:nvPr/>
+        </p:nvSpPr>
+        <p:spPr>
+          <a:xfrm>
+            <a:off x="8115300" y="5514975"/>
+            <a:ext cx="723900" cy="133350"/>
+          </a:xfrm>
+          <a:prstGeom prst="rect">
+            <a:avLst/>
+          </a:prstGeom>
+          <a:noFill/>
+        </p:spPr>
+        <p:txBody>
+          <a:bodyPr anchor="ctr"/>
+          <a:lstStyle/>
+          <a:p>
+            <a:pPr algn="ctr"/>
+            <a:r>
+              <a:rPr sz="600">
+                <a:solidFill>
+                  <a:srgbClr val="666666"/>
+                </a:solidFill>
+              </a:rPr>
+              <a:t>accentCallout2</a:t>
+            </a:r>
+          </a:p>
+        </p:txBody>
+      </p:sp>
+      <p:sp>
+        <p:nvSpPr>
+          <p:cNvPr id="381" name="accentCallout3"/>
+          <p:cNvSpPr/>
+          <p:nvPr/>
+        </p:nvSpPr>
+        <p:spPr>
+          <a:xfrm>
+            <a:off x="8963025" y="5181600"/>
+            <a:ext cx="476250" cy="323850"/>
+          </a:xfrm>
+          <a:prstGeom prst="accentCallout3">
+            <a:avLst/>
+          </a:prstGeom>
+          <a:solidFill>
+            <a:schemeClr val="accent3"/>
+          </a:solidFill>
+          <a:ln w="9525">
+            <a:solidFill>
+              <a:schemeClr val="tx2"/>
+            </a:solidFill>
+          </a:ln>
+        </p:spPr>
+        <p:txBody>
+          <a:bodyPr anchor="ctr"/>
+          <a:lstStyle/>
+          <a:p>
+            <a:endParaRPr/>
+          </a:p>
+        </p:txBody>
+      </p:sp>
+      <p:sp>
+        <p:nvSpPr>
+          <p:cNvPr id="382" name="sp"/>
+          <p:cNvSpPr/>
+          <p:nvPr/>
+        </p:nvSpPr>
+        <p:spPr>
+          <a:xfrm>
+            <a:off x="8839200" y="5514975"/>
+            <a:ext cx="723900" cy="133350"/>
+          </a:xfrm>
+          <a:prstGeom prst="rect">
+            <a:avLst/>
+          </a:prstGeom>
+          <a:noFill/>
+        </p:spPr>
+        <p:txBody>
+          <a:bodyPr anchor="ctr"/>
+          <a:lstStyle/>
+          <a:p>
+            <a:pPr algn="ctr"/>
+            <a:r>
+              <a:rPr sz="600">
+                <a:solidFill>
+                  <a:srgbClr val="666666"/>
+                </a:solidFill>
+              </a:rPr>
+              <a:t>accentCallout3</a:t>
+            </a:r>
+          </a:p>
+        </p:txBody>
+      </p:sp>
+      <p:sp>
+        <p:nvSpPr>
+          <p:cNvPr id="383" name="accentBorderCallout1"/>
+          <p:cNvSpPr/>
+          <p:nvPr/>
+        </p:nvSpPr>
+        <p:spPr>
+          <a:xfrm>
+            <a:off x="9686925" y="5181600"/>
+            <a:ext cx="476250" cy="323850"/>
+          </a:xfrm>
+          <a:prstGeom prst="accentBorderCallout1">
+            <a:avLst/>
+          </a:prstGeom>
+          <a:solidFill>
+            <a:schemeClr val="accent4"/>
+          </a:solidFill>
+          <a:ln w="9525">
+            <a:solidFill>
+              <a:schemeClr val="tx2"/>
+            </a:solidFill>
+          </a:ln>
+        </p:spPr>
+        <p:txBody>
+          <a:bodyPr anchor="ctr"/>
+          <a:lstStyle/>
+          <a:p>
+            <a:endParaRPr/>
+          </a:p>
+        </p:txBody>
+      </p:sp>
+      <p:sp>
+        <p:nvSpPr>
+          <p:cNvPr id="384" name="sp"/>
+          <p:cNvSpPr/>
+          <p:nvPr/>
+        </p:nvSpPr>
+        <p:spPr>
+          <a:xfrm>
+            <a:off x="9563100" y="5514975"/>
+            <a:ext cx="723900" cy="133350"/>
+          </a:xfrm>
+          <a:prstGeom prst="rect">
+            <a:avLst/>
+          </a:prstGeom>
+          <a:noFill/>
+        </p:spPr>
+        <p:txBody>
+          <a:bodyPr anchor="ctr"/>
+          <a:lstStyle/>
+          <a:p>
+            <a:pPr algn="ctr"/>
+            <a:r>
+              <a:rPr sz="600">
+                <a:solidFill>
+                  <a:srgbClr val="666666"/>
+                </a:solidFill>
+              </a:rPr>
+              <a:t>accentBorderCallout1</a:t>
+            </a:r>
+          </a:p>
+        </p:txBody>
+      </p:sp>
+      <p:sp>
+        <p:nvSpPr>
+          <p:cNvPr id="385" name="accentBorderCallout2"/>
+          <p:cNvSpPr/>
+          <p:nvPr/>
+        </p:nvSpPr>
+        <p:spPr>
+          <a:xfrm>
+            <a:off x="10410825" y="5181600"/>
+            <a:ext cx="476250" cy="323850"/>
+          </a:xfrm>
+          <a:prstGeom prst="accentBorderCallout2">
+            <a:avLst/>
+          </a:prstGeom>
+          <a:solidFill>
+            <a:schemeClr val="accent5"/>
+          </a:solidFill>
+          <a:ln w="9525">
+            <a:solidFill>
+              <a:schemeClr val="tx2"/>
+            </a:solidFill>
+          </a:ln>
+        </p:spPr>
+        <p:txBody>
+          <a:bodyPr anchor="ctr"/>
+          <a:lstStyle/>
+          <a:p>
+            <a:endParaRPr/>
+          </a:p>
+        </p:txBody>
+      </p:sp>
+      <p:sp>
+        <p:nvSpPr>
+          <p:cNvPr id="386" name="sp"/>
+          <p:cNvSpPr/>
+          <p:nvPr/>
+        </p:nvSpPr>
+        <p:spPr>
+          <a:xfrm>
+            <a:off x="10287000" y="5514975"/>
+            <a:ext cx="723900" cy="133350"/>
+          </a:xfrm>
+          <a:prstGeom prst="rect">
+            <a:avLst/>
+          </a:prstGeom>
+          <a:noFill/>
+        </p:spPr>
+        <p:txBody>
+          <a:bodyPr anchor="ctr"/>
+          <a:lstStyle/>
+          <a:p>
+            <a:pPr algn="ctr"/>
+            <a:r>
+              <a:rPr sz="600">
+                <a:solidFill>
+                  <a:srgbClr val="666666"/>
+                </a:solidFill>
+              </a:rPr>
+              <a:t>accentBorderCallout2</a:t>
+            </a:r>
+          </a:p>
+        </p:txBody>
+      </p:sp>
+      <p:sp>
+        <p:nvSpPr>
+          <p:cNvPr id="387" name="accentBorderCallout3"/>
+          <p:cNvSpPr/>
+          <p:nvPr/>
+        </p:nvSpPr>
+        <p:spPr>
+          <a:xfrm>
+            <a:off x="11134725" y="5181600"/>
+            <a:ext cx="476250" cy="323850"/>
+          </a:xfrm>
+          <a:prstGeom prst="accentBorderCallout3">
+            <a:avLst/>
+          </a:prstGeom>
+          <a:solidFill>
+            <a:schemeClr val="accent6"/>
+          </a:solidFill>
+          <a:ln w="9525">
+            <a:solidFill>
+              <a:schemeClr val="tx2"/>
+            </a:solidFill>
+          </a:ln>
+        </p:spPr>
+        <p:txBody>
+          <a:bodyPr anchor="ctr"/>
+          <a:lstStyle/>
+          <a:p>
+            <a:endParaRPr/>
+          </a:p>
+        </p:txBody>
+      </p:sp>
+      <p:sp>
+        <p:nvSpPr>
+          <p:cNvPr id="388" name="sp"/>
+          <p:cNvSpPr/>
+          <p:nvPr/>
+        </p:nvSpPr>
+        <p:spPr>
+          <a:xfrm>
+            <a:off x="11010900" y="5514975"/>
+            <a:ext cx="723900" cy="133350"/>
+          </a:xfrm>
+          <a:prstGeom prst="rect">
+            <a:avLst/>
+          </a:prstGeom>
+          <a:noFill/>
+        </p:spPr>
+        <p:txBody>
+          <a:bodyPr anchor="ctr"/>
+          <a:lstStyle/>
+          <a:p>
+            <a:pPr algn="ctr"/>
+            <a:r>
+              <a:rPr sz="600">
+                <a:solidFill>
+                  <a:srgbClr val="666666"/>
+                </a:solidFill>
+              </a:rPr>
+              <a:t>accentBorderCallout3</a:t>
             </a:r>
           </a:p>
         </p:txBody>
@@ -8107,7 +9619,7 @@
       </p:grpSpPr>
       <p:sp>
         <p:nvSpPr>
-          <p:cNvPr id="342" name="sp"/>
+          <p:cNvPr id="390" name="sp"/>
           <p:cNvSpPr/>
           <p:nvPr/>
         </p:nvSpPr>
@@ -8138,7 +9650,7 @@
       </p:sp>
       <p:sp>
         <p:nvSpPr>
-          <p:cNvPr id="343" name="sp"/>
+          <p:cNvPr id="391" name="sp"/>
           <p:cNvSpPr/>
           <p:nvPr/>
         </p:nvSpPr>
@@ -8179,7 +9691,7 @@
       </p:sp>
       <p:sp>
         <p:nvSpPr>
-          <p:cNvPr id="344" name="sp"/>
+          <p:cNvPr id="392" name="sp"/>
           <p:cNvSpPr/>
           <p:nvPr/>
         </p:nvSpPr>
@@ -8220,7 +9732,7 @@
       </p:sp>
       <p:sp>
         <p:nvSpPr>
-          <p:cNvPr id="345" name="sp"/>
+          <p:cNvPr id="393" name="sp"/>
           <p:cNvSpPr/>
           <p:nvPr/>
         </p:nvSpPr>
@@ -8257,7 +9769,7 @@
       </p:sp>
       <p:sp>
         <p:nvSpPr>
-          <p:cNvPr id="346" name="sp"/>
+          <p:cNvPr id="394" name="sp"/>
           <p:cNvSpPr/>
           <p:nvPr/>
         </p:nvSpPr>
@@ -8301,7 +9813,7 @@
       </p:sp>
       <p:sp>
         <p:nvSpPr>
-          <p:cNvPr id="347" name="sp"/>
+          <p:cNvPr id="395" name="sp"/>
           <p:cNvSpPr/>
           <p:nvPr/>
         </p:nvSpPr>
@@ -8340,7 +9852,7 @@
       </p:sp>
       <p:sp>
         <p:nvSpPr>
-          <p:cNvPr id="348" name="sp"/>
+          <p:cNvPr id="396" name="sp"/>
           <p:cNvSpPr/>
           <p:nvPr/>
         </p:nvSpPr>
@@ -8372,7 +9884,7 @@
       </p:sp>
       <p:sp>
         <p:nvSpPr>
-          <p:cNvPr id="349" name="sp"/>
+          <p:cNvPr id="397" name="sp"/>
           <p:cNvSpPr/>
           <p:nvPr/>
         </p:nvSpPr>
@@ -8414,7 +9926,7 @@
       </p:sp>
       <p:sp>
         <p:nvSpPr>
-          <p:cNvPr id="350" name="sp"/>
+          <p:cNvPr id="398" name="sp"/>
           <p:cNvSpPr/>
           <p:nvPr/>
         </p:nvSpPr>
@@ -8446,7 +9958,7 @@
       </p:sp>
       <p:sp>
         <p:nvSpPr>
-          <p:cNvPr id="351" name="sp"/>
+          <p:cNvPr id="399" name="sp"/>
           <p:cNvSpPr/>
           <p:nvPr/>
         </p:nvSpPr>
@@ -8487,7 +9999,7 @@
       </p:sp>
       <p:sp>
         <p:nvSpPr>
-          <p:cNvPr id="352" name="sp"/>
+          <p:cNvPr id="400" name="sp"/>
           <p:cNvSpPr/>
           <p:nvPr/>
         </p:nvSpPr>
@@ -8519,7 +10031,7 @@
       </p:sp>
       <p:sp>
         <p:nvSpPr>
-          <p:cNvPr id="353" name="sp"/>
+          <p:cNvPr id="401" name="sp"/>
           <p:cNvSpPr/>
           <p:nvPr/>
         </p:nvSpPr>
@@ -8555,7 +10067,7 @@
       </p:sp>
       <p:sp>
         <p:nvSpPr>
-          <p:cNvPr id="354" name="sp"/>
+          <p:cNvPr id="402" name="sp"/>
           <p:cNvSpPr/>
           <p:nvPr/>
         </p:nvSpPr>
@@ -8587,7 +10099,7 @@
       </p:sp>
       <p:sp>
         <p:nvSpPr>
-          <p:cNvPr id="355" name="sp"/>
+          <p:cNvPr id="403" name="sp"/>
           <p:cNvSpPr/>
           <p:nvPr/>
         </p:nvSpPr>
@@ -8623,7 +10135,7 @@
       </p:sp>
       <p:sp>
         <p:nvSpPr>
-          <p:cNvPr id="356" name="sp"/>
+          <p:cNvPr id="404" name="sp"/>
           <p:cNvSpPr/>
           <p:nvPr/>
         </p:nvSpPr>
@@ -8655,7 +10167,7 @@
       </p:sp>
       <p:sp>
         <p:nvSpPr>
-          <p:cNvPr id="357" name="sp"/>
+          <p:cNvPr id="405" name="sp"/>
           <p:cNvSpPr/>
           <p:nvPr/>
         </p:nvSpPr>
@@ -8688,7 +10200,7 @@
       </p:sp>
       <p:sp>
         <p:nvSpPr>
-          <p:cNvPr id="358" name="sp"/>
+          <p:cNvPr id="406" name="sp"/>
           <p:cNvSpPr/>
           <p:nvPr/>
         </p:nvSpPr>
@@ -8720,7 +10232,7 @@
       </p:sp>
       <p:sp>
         <p:nvSpPr>
-          <p:cNvPr id="359" name="sp"/>
+          <p:cNvPr id="407" name="sp"/>
           <p:cNvSpPr/>
           <p:nvPr/>
         </p:nvSpPr>
@@ -8753,7 +10265,7 @@
       </p:sp>
       <p:sp>
         <p:nvSpPr>
-          <p:cNvPr id="360" name="sp"/>
+          <p:cNvPr id="408" name="sp"/>
           <p:cNvSpPr/>
           <p:nvPr/>
         </p:nvSpPr>
@@ -8785,7 +10297,7 @@
       </p:sp>
       <p:sp>
         <p:nvSpPr>
-          <p:cNvPr id="361" name="sp"/>
+          <p:cNvPr id="409" name="sp"/>
           <p:cNvSpPr/>
           <p:nvPr/>
         </p:nvSpPr>
@@ -8818,7 +10330,7 @@
       </p:sp>
       <p:sp>
         <p:nvSpPr>
-          <p:cNvPr id="362" name="sp"/>
+          <p:cNvPr id="410" name="sp"/>
           <p:cNvSpPr/>
           <p:nvPr/>
         </p:nvSpPr>
@@ -8878,7 +10390,7 @@
       </p:grpSpPr>
       <p:sp>
         <p:nvSpPr>
-          <p:cNvPr id="363" name="sp"/>
+          <p:cNvPr id="411" name="sp"/>
           <p:cNvSpPr/>
           <p:nvPr/>
         </p:nvSpPr>
@@ -8932,7 +10444,7 @@
       </p:cxnSp>
       <p:sp>
         <p:nvSpPr>
-          <p:cNvPr id="364" name="sp"/>
+          <p:cNvPr id="412" name="sp"/>
           <p:cNvSpPr/>
           <p:nvPr/>
         </p:nvSpPr>
@@ -8987,7 +10499,7 @@
       </p:cxnSp>
       <p:sp>
         <p:nvSpPr>
-          <p:cNvPr id="365" name="sp"/>
+          <p:cNvPr id="413" name="sp"/>
           <p:cNvSpPr/>
           <p:nvPr/>
         </p:nvSpPr>
@@ -9042,7 +10554,7 @@
       </p:cxnSp>
       <p:sp>
         <p:nvSpPr>
-          <p:cNvPr id="366" name="sp"/>
+          <p:cNvPr id="414" name="sp"/>
           <p:cNvSpPr/>
           <p:nvPr/>
         </p:nvSpPr>
@@ -9097,7 +10609,7 @@
       </p:cxnSp>
       <p:sp>
         <p:nvSpPr>
-          <p:cNvPr id="367" name="sp"/>
+          <p:cNvPr id="415" name="sp"/>
           <p:cNvSpPr/>
           <p:nvPr/>
         </p:nvSpPr>
@@ -9152,7 +10664,7 @@
       </p:cxnSp>
       <p:sp>
         <p:nvSpPr>
-          <p:cNvPr id="368" name="sp"/>
+          <p:cNvPr id="416" name="sp"/>
           <p:cNvSpPr/>
           <p:nvPr/>
         </p:nvSpPr>
@@ -9207,7 +10719,7 @@
       </p:cxnSp>
       <p:sp>
         <p:nvSpPr>
-          <p:cNvPr id="369" name="sp"/>
+          <p:cNvPr id="417" name="sp"/>
           <p:cNvSpPr/>
           <p:nvPr/>
         </p:nvSpPr>
@@ -9261,7 +10773,7 @@
       </p:cxnSp>
       <p:sp>
         <p:nvSpPr>
-          <p:cNvPr id="370" name="sp"/>
+          <p:cNvPr id="418" name="sp"/>
           <p:cNvSpPr/>
           <p:nvPr/>
         </p:nvSpPr>
@@ -9315,7 +10827,7 @@
       </p:cxnSp>
       <p:sp>
         <p:nvSpPr>
-          <p:cNvPr id="371" name="sp"/>
+          <p:cNvPr id="419" name="sp"/>
           <p:cNvSpPr/>
           <p:nvPr/>
         </p:nvSpPr>
@@ -9369,7 +10881,7 @@
       </p:cxnSp>
       <p:sp>
         <p:nvSpPr>
-          <p:cNvPr id="372" name="sp"/>
+          <p:cNvPr id="420" name="sp"/>
           <p:cNvSpPr/>
           <p:nvPr/>
         </p:nvSpPr>
@@ -9423,7 +10935,7 @@
       </p:cxnSp>
       <p:sp>
         <p:nvSpPr>
-          <p:cNvPr id="373" name="sp"/>
+          <p:cNvPr id="421" name="sp"/>
           <p:cNvSpPr/>
           <p:nvPr/>
         </p:nvSpPr>
@@ -9477,7 +10989,7 @@
       </p:cxnSp>
       <p:sp>
         <p:nvSpPr>
-          <p:cNvPr id="374" name="sp"/>
+          <p:cNvPr id="422" name="sp"/>
           <p:cNvSpPr/>
           <p:nvPr/>
         </p:nvSpPr>
@@ -9531,7 +11043,7 @@
       </p:cxnSp>
       <p:sp>
         <p:nvSpPr>
-          <p:cNvPr id="375" name="sp"/>
+          <p:cNvPr id="423" name="sp"/>
           <p:cNvSpPr/>
           <p:nvPr/>
         </p:nvSpPr>
@@ -9585,7 +11097,7 @@
       </p:cxnSp>
       <p:sp>
         <p:nvSpPr>
-          <p:cNvPr id="376" name="sp"/>
+          <p:cNvPr id="424" name="sp"/>
           <p:cNvSpPr/>
           <p:nvPr/>
         </p:nvSpPr>
@@ -9639,7 +11151,7 @@
       </p:cxnSp>
       <p:sp>
         <p:nvSpPr>
-          <p:cNvPr id="377" name="sp"/>
+          <p:cNvPr id="425" name="sp"/>
           <p:cNvSpPr/>
           <p:nvPr/>
         </p:nvSpPr>
@@ -9693,7 +11205,7 @@
       </p:cxnSp>
       <p:sp>
         <p:nvSpPr>
-          <p:cNvPr id="378" name="sp"/>
+          <p:cNvPr id="426" name="sp"/>
           <p:cNvSpPr/>
           <p:nvPr/>
         </p:nvSpPr>
@@ -9747,7 +11259,7 @@
       </p:cxnSp>
       <p:sp>
         <p:nvSpPr>
-          <p:cNvPr id="379" name="sp"/>
+          <p:cNvPr id="427" name="sp"/>
           <p:cNvSpPr/>
           <p:nvPr/>
         </p:nvSpPr>
@@ -9801,7 +11313,7 @@
       </p:cxnSp>
       <p:sp>
         <p:nvSpPr>
-          <p:cNvPr id="380" name="sp"/>
+          <p:cNvPr id="428" name="sp"/>
           <p:cNvSpPr/>
           <p:nvPr/>
         </p:nvSpPr>
@@ -9854,7 +11366,7 @@
       </p:cxnSp>
       <p:sp>
         <p:nvSpPr>
-          <p:cNvPr id="381" name="sp"/>
+          <p:cNvPr id="429" name="sp"/>
           <p:cNvSpPr/>
           <p:nvPr/>
         </p:nvSpPr>
@@ -9907,7 +11419,7 @@
       </p:cxnSp>
       <p:sp>
         <p:nvSpPr>
-          <p:cNvPr id="382" name="sp"/>
+          <p:cNvPr id="430" name="sp"/>
           <p:cNvSpPr/>
           <p:nvPr/>
         </p:nvSpPr>
@@ -9960,7 +11472,7 @@
       </p:cxnSp>
       <p:sp>
         <p:nvSpPr>
-          <p:cNvPr id="383" name="sp"/>
+          <p:cNvPr id="431" name="sp"/>
           <p:cNvSpPr/>
           <p:nvPr/>
         </p:nvSpPr>
@@ -10020,7 +11532,7 @@
       </p:grpSpPr>
       <p:sp>
         <p:nvSpPr>
-          <p:cNvPr id="384" name="sp"/>
+          <p:cNvPr id="432" name="sp"/>
           <p:cNvSpPr/>
           <p:nvPr/>
         </p:nvSpPr>
@@ -10445,7 +11957,7 @@
       </p:sp>
       <p:sp>
         <p:nvSpPr>
-          <p:cNvPr id="385" name="sp"/>
+          <p:cNvPr id="433" name="sp"/>
           <p:cNvSpPr/>
           <p:nvPr/>
         </p:nvSpPr>
@@ -10479,7 +11991,7 @@
       </p:sp>
       <p:sp>
         <p:nvSpPr>
-          <p:cNvPr id="386" name="sp"/>
+          <p:cNvPr id="434" name="sp"/>
           <p:cNvSpPr/>
           <p:nvPr/>
         </p:nvSpPr>
@@ -10513,7 +12025,7 @@
       </p:sp>
       <p:sp>
         <p:nvSpPr>
-          <p:cNvPr id="387" name="sp"/>
+          <p:cNvPr id="435" name="sp"/>
           <p:cNvSpPr/>
           <p:nvPr/>
         </p:nvSpPr>
@@ -10547,7 +12059,7 @@
       </p:sp>
       <p:sp>
         <p:nvSpPr>
-          <p:cNvPr id="388" name="sp"/>
+          <p:cNvPr id="436" name="sp"/>
           <p:cNvSpPr/>
           <p:nvPr/>
         </p:nvSpPr>
@@ -10609,7 +12121,7 @@
       </p:grpSpPr>
       <p:sp>
         <p:nvSpPr>
-          <p:cNvPr id="389" name="sp"/>
+          <p:cNvPr id="437" name="sp"/>
           <p:cNvSpPr/>
           <p:nvPr/>
         </p:nvSpPr>
@@ -11077,7 +12589,7 @@
       </p:pic>
       <p:sp>
         <p:nvSpPr>
-          <p:cNvPr id="390" name="sp"/>
+          <p:cNvPr id="438" name="sp"/>
           <p:cNvSpPr/>
           <p:nvPr/>
         </p:nvSpPr>
@@ -11132,7 +12644,7 @@
       </p:pic>
       <p:sp>
         <p:nvSpPr>
-          <p:cNvPr id="391" name="sp"/>
+          <p:cNvPr id="439" name="sp"/>
           <p:cNvSpPr/>
           <p:nvPr/>
         </p:nvSpPr>
@@ -11186,7 +12698,7 @@
       </p:pic>
       <p:sp>
         <p:nvSpPr>
-          <p:cNvPr id="392" name="sp"/>
+          <p:cNvPr id="440" name="sp"/>
           <p:cNvSpPr/>
           <p:nvPr/>
         </p:nvSpPr>
@@ -11240,7 +12752,7 @@
       </p:pic>
       <p:sp>
         <p:nvSpPr>
-          <p:cNvPr id="393" name="sp"/>
+          <p:cNvPr id="441" name="sp"/>
           <p:cNvSpPr/>
           <p:nvPr/>
         </p:nvSpPr>
@@ -11272,7 +12784,7 @@
       </p:sp>
       <p:sp>
         <p:nvSpPr>
-          <p:cNvPr id="394" name="sp"/>
+          <p:cNvPr id="442" name="sp"/>
           <p:cNvSpPr/>
           <p:nvPr/>
         </p:nvSpPr>
@@ -11302,7 +12814,7 @@
       </p:sp>
       <p:sp>
         <p:nvSpPr>
-          <p:cNvPr id="395" name="sp"/>
+          <p:cNvPr id="443" name="sp"/>
           <p:cNvSpPr/>
           <p:nvPr/>
         </p:nvSpPr>
@@ -11331,7 +12843,7 @@
       </p:sp>
       <p:sp>
         <p:nvSpPr>
-          <p:cNvPr id="396" name="sp"/>
+          <p:cNvPr id="444" name="sp"/>
           <p:cNvSpPr/>
           <p:nvPr/>
         </p:nvSpPr>
@@ -11363,7 +12875,7 @@
       </p:sp>
       <p:sp>
         <p:nvSpPr>
-          <p:cNvPr id="397" name="sp"/>
+          <p:cNvPr id="445" name="sp"/>
           <p:cNvSpPr/>
           <p:nvPr/>
         </p:nvSpPr>
@@ -11423,7 +12935,7 @@
       </p:grpSpPr>
       <p:sp>
         <p:nvSpPr>
-          <p:cNvPr id="401" name="sp"/>
+          <p:cNvPr id="449" name="sp"/>
           <p:cNvSpPr/>
           <p:nvPr/>
         </p:nvSpPr>
@@ -11574,7 +13086,7 @@
         </p:grpSpPr>
         <p:sp>
           <p:nvSpPr>
-            <p:cNvPr id="398" name="sp"/>
+            <p:cNvPr id="446" name="sp"/>
             <p:cNvSpPr/>
             <p:nvPr/>
           </p:nvSpPr>
@@ -11622,7 +13134,7 @@
           </p:grpSpPr>
           <p:sp>
             <p:nvSpPr>
-              <p:cNvPr id="399" name="sp"/>
+              <p:cNvPr id="447" name="sp"/>
               <p:cNvSpPr/>
               <p:nvPr/>
             </p:nvSpPr>
@@ -11656,7 +13168,7 @@
           </p:sp>
           <p:sp>
             <p:nvSpPr>
-              <p:cNvPr id="400" name="sp"/>
+              <p:cNvPr id="448" name="sp"/>
               <p:cNvSpPr/>
               <p:nvPr/>
             </p:nvSpPr>
@@ -11692,7 +13204,7 @@
       </p:grpSp>
       <p:sp>
         <p:nvSpPr>
-          <p:cNvPr id="402" name="sp"/>
+          <p:cNvPr id="450" name="sp"/>
           <p:cNvSpPr/>
           <p:nvPr/>
         </p:nvSpPr>
@@ -11724,7 +13236,7 @@
       </p:sp>
       <p:sp>
         <p:nvSpPr>
-          <p:cNvPr id="403" name="sp"/>
+          <p:cNvPr id="451" name="sp"/>
           <p:cNvSpPr/>
           <p:nvPr/>
         </p:nvSpPr>
@@ -11756,7 +13268,7 @@
       </p:sp>
       <p:sp>
         <p:nvSpPr>
-          <p:cNvPr id="404" name="sp"/>
+          <p:cNvPr id="452" name="sp"/>
           <p:cNvSpPr/>
           <p:nvPr/>
         </p:nvSpPr>
@@ -11788,7 +13300,7 @@
       </p:sp>
       <p:sp>
         <p:nvSpPr>
-          <p:cNvPr id="405" name="sp"/>
+          <p:cNvPr id="453" name="sp"/>
           <p:cNvSpPr/>
           <p:nvPr/>
         </p:nvSpPr>
@@ -11824,7 +13336,7 @@
       </p:sp>
       <p:sp>
         <p:nvSpPr>
-          <p:cNvPr id="406" name="sp"/>
+          <p:cNvPr id="454" name="sp"/>
           <p:cNvSpPr/>
           <p:nvPr/>
         </p:nvSpPr>
@@ -11860,7 +13372,7 @@
       </p:sp>
       <p:sp>
         <p:nvSpPr>
-          <p:cNvPr id="407" name="sp"/>
+          <p:cNvPr id="455" name="sp"/>
           <p:cNvSpPr/>
           <p:nvPr/>
         </p:nvSpPr>
@@ -11896,7 +13408,7 @@
       </p:sp>
       <p:sp>
         <p:nvSpPr>
-          <p:cNvPr id="408" name="sp"/>
+          <p:cNvPr id="456" name="sp"/>
           <p:cNvSpPr/>
           <p:nvPr/>
         </p:nvSpPr>
@@ -11924,7 +13436,7 @@
       </p:sp>
       <p:sp>
         <p:nvSpPr>
-          <p:cNvPr id="409" name="sp"/>
+          <p:cNvPr id="457" name="sp"/>
           <p:cNvSpPr/>
           <p:nvPr/>
         </p:nvSpPr>
@@ -11952,7 +13464,7 @@
       </p:sp>
       <p:sp>
         <p:nvSpPr>
-          <p:cNvPr id="410" name="sp"/>
+          <p:cNvPr id="458" name="sp"/>
           <p:cNvSpPr/>
           <p:nvPr/>
         </p:nvSpPr>
@@ -11980,7 +13492,7 @@
       </p:sp>
       <p:sp>
         <p:nvSpPr>
-          <p:cNvPr id="411" name="sp"/>
+          <p:cNvPr id="459" name="sp"/>
           <p:cNvSpPr/>
           <p:nvPr/>
         </p:nvSpPr>
@@ -12009,7 +13521,7 @@
       </p:sp>
       <p:sp>
         <p:nvSpPr>
-          <p:cNvPr id="412" name="sp"/>
+          <p:cNvPr id="460" name="sp"/>
           <p:cNvSpPr/>
           <p:nvPr/>
         </p:nvSpPr>
@@ -12038,7 +13550,7 @@
       </p:sp>
       <p:sp>
         <p:nvSpPr>
-          <p:cNvPr id="413" name="sp"/>
+          <p:cNvPr id="461" name="sp"/>
           <p:cNvSpPr/>
           <p:nvPr/>
         </p:nvSpPr>
@@ -12067,7 +13579,7 @@
       </p:sp>
       <p:sp>
         <p:nvSpPr>
-          <p:cNvPr id="414" name="sp"/>
+          <p:cNvPr id="462" name="sp"/>
           <p:cNvSpPr/>
           <p:nvPr/>
         </p:nvSpPr>
@@ -12097,7 +13609,7 @@
       </p:sp>
       <p:sp>
         <p:nvSpPr>
-          <p:cNvPr id="415" name="sp"/>
+          <p:cNvPr id="463" name="sp"/>
           <p:cNvSpPr/>
           <p:nvPr/>
         </p:nvSpPr>
@@ -12127,7 +13639,7 @@
       </p:sp>
       <p:sp>
         <p:nvSpPr>
-          <p:cNvPr id="416" name="sp"/>
+          <p:cNvPr id="464" name="sp"/>
           <p:cNvSpPr/>
           <p:nvPr/>
         </p:nvSpPr>
@@ -12187,7 +13699,7 @@
       </p:grpSpPr>
       <p:sp>
         <p:nvSpPr>
-          <p:cNvPr id="417" name="sp"/>
+          <p:cNvPr id="465" name="sp"/>
           <p:cNvSpPr/>
           <p:nvPr/>
         </p:nvSpPr>
@@ -12218,7 +13730,7 @@
       </p:sp>
       <p:sp>
         <p:nvSpPr>
-          <p:cNvPr id="418" name="挤出 6pt"/>
+          <p:cNvPr id="466" name="挤出 6pt"/>
           <p:cNvSpPr/>
           <p:nvPr/>
         </p:nvSpPr>
@@ -12255,7 +13767,7 @@
       </p:sp>
       <p:sp>
         <p:nvSpPr>
-          <p:cNvPr id="419" name="sp"/>
+          <p:cNvPr id="467" name="sp"/>
           <p:cNvSpPr/>
           <p:nvPr/>
         </p:nvSpPr>
@@ -12287,7 +13799,7 @@
       </p:sp>
       <p:sp>
         <p:nvSpPr>
-          <p:cNvPr id="420" name="挤出 12pt"/>
+          <p:cNvPr id="468" name="挤出 12pt"/>
           <p:cNvSpPr/>
           <p:nvPr/>
         </p:nvSpPr>
@@ -12324,7 +13836,7 @@
       </p:sp>
       <p:sp>
         <p:nvSpPr>
-          <p:cNvPr id="421" name="sp"/>
+          <p:cNvPr id="469" name="sp"/>
           <p:cNvSpPr/>
           <p:nvPr/>
         </p:nvSpPr>
@@ -12356,7 +13868,7 @@
       </p:sp>
       <p:sp>
         <p:nvSpPr>
-          <p:cNvPr id="422" name="挤出 + 斜角"/>
+          <p:cNvPr id="470" name="挤出 + 斜角"/>
           <p:cNvSpPr/>
           <p:nvPr/>
         </p:nvSpPr>
@@ -12394,7 +13906,7 @@
       </p:sp>
       <p:sp>
         <p:nvSpPr>
-          <p:cNvPr id="423" name="sp"/>
+          <p:cNvPr id="471" name="sp"/>
           <p:cNvSpPr/>
           <p:nvPr/>
         </p:nvSpPr>
@@ -12426,7 +13938,7 @@
       </p:sp>
       <p:sp>
         <p:nvSpPr>
-          <p:cNvPr id="424" name="挤出 + 轮廓"/>
+          <p:cNvPr id="472" name="挤出 + 轮廓"/>
           <p:cNvSpPr/>
           <p:nvPr/>
         </p:nvSpPr>
@@ -12466,7 +13978,7 @@
       </p:sp>
       <p:sp>
         <p:nvSpPr>
-          <p:cNvPr id="425" name="sp"/>
+          <p:cNvPr id="473" name="sp"/>
           <p:cNvSpPr/>
           <p:nvPr/>
         </p:nvSpPr>
@@ -12498,7 +14010,7 @@
       </p:sp>
       <p:sp>
         <p:nvSpPr>
-          <p:cNvPr id="426" name="金属材质"/>
+          <p:cNvPr id="474" name="金属材质"/>
           <p:cNvSpPr/>
           <p:nvPr/>
         </p:nvSpPr>
@@ -12536,7 +14048,7 @@
       </p:sp>
       <p:sp>
         <p:nvSpPr>
-          <p:cNvPr id="427" name="sp"/>
+          <p:cNvPr id="475" name="sp"/>
           <p:cNvSpPr/>
           <p:nvPr/>
         </p:nvSpPr>
@@ -12568,7 +14080,7 @@
       </p:sp>
       <p:sp>
         <p:nvSpPr>
-          <p:cNvPr id="428" name="旋转视角"/>
+          <p:cNvPr id="476" name="旋转视角"/>
           <p:cNvSpPr/>
           <p:nvPr/>
         </p:nvSpPr>
@@ -12608,7 +14120,7 @@
       </p:sp>
       <p:sp>
         <p:nvSpPr>
-          <p:cNvPr id="429" name="sp"/>
+          <p:cNvPr id="477" name="sp"/>
           <p:cNvSpPr/>
           <p:nvPr/>
         </p:nvSpPr>
@@ -12640,7 +14152,7 @@
       </p:sp>
       <p:sp>
         <p:nvSpPr>
-          <p:cNvPr id="430" name="sp"/>
+          <p:cNvPr id="478" name="sp"/>
           <p:cNvSpPr/>
           <p:nvPr/>
         </p:nvSpPr>

</xml_diff>

<commit_message>
feat(transition): 支持 p14 全部 19 种切换与 p159 morph
原先 TRANSITION_TAGS 只有 ECMA-376 原生的 21 种，PowerPoint 2010+ 的扩展
一律落到默认值 fade。findTransition 本来就会钻进 mc:AlternateContent 的
Choice 分支、解析又与命名空间无关，所以补上名字即可命中。

morph 是真做的逐元素形变，不是淡入：按 data-el（形状 id）在前后两页之间
配对，配上的做几何补间（translate + scale），配对上的旧元素立刻置 0 避免
双影，其余淡入淡出。PowerPoint 自己也是按形状 id 匹配——morph 版面基本都由
「复制上一页再改」得来，id 天然一致。byWord / byChar 的细粒度拆分不做。

其余 19 种原版是 GPU 网格变形，DOM 里没有对等物，取每种最有辨识度的那一维
（旋转轴 / 缩放中心 / 裁剪形状）做近似，保证互相看得出区别。

顺带修一个真 bug：后台标签页的 document timeline 是暂停的，
Animation.finished 永不 resolve，切换的收尾逻辑（移除旧图层）就永远不执行，
配合自动换片会让图层一层层堆积。加 settle() 超时兜底。

Co-Authored-By: Claude Opus 5 <noreply@anthropic.com>
</commit_message>
<xml_diff>
--- a/fixtures/showcase.pptx
+++ b/fixtures/showcase.pptx
@@ -11504,9 +11504,18 @@
       </p:sp>
     </p:spTree>
   </p:cSld>
-  <p:transition spd="med">
-    <p:wipe dir="d"/>
-  </p:transition>
+  <mc:AlternateContent xmlns:mc="http://schemas.openxmlformats.org/markup-compatibility/2006">
+    <mc:Choice xmlns:p14="http://schemas.microsoft.com/office/powerpoint/2010/main" xmlns:p159="http://schemas.microsoft.com/office/powerpoint/2015/09/main" Requires="p14">
+      <p:transition spd="slow" p14:dur="1400">
+        <p14:ripple/>
+      </p:transition>
+    </mc:Choice>
+    <mc:Fallback>
+      <p:transition spd="slow">
+        <p:circle/>
+      </p:transition>
+    </mc:Fallback>
+  </mc:AlternateContent>
   <p:clrMapOvr>
     <a:masterClrMapping/>
   </p:clrMapOvr>
@@ -12093,9 +12102,18 @@
       </p:sp>
     </p:spTree>
   </p:cSld>
-  <p:transition spd="fast">
-    <p:cover dir="u"/>
-  </p:transition>
+  <mc:AlternateContent xmlns:mc="http://schemas.openxmlformats.org/markup-compatibility/2006">
+    <mc:Choice xmlns:p14="http://schemas.microsoft.com/office/powerpoint/2010/main" xmlns:p159="http://schemas.microsoft.com/office/powerpoint/2015/09/main" Requires="p159">
+      <p:transition spd="slow" p14:dur="1400">
+        <p159:morph option="byObject"/>
+      </p:transition>
+    </mc:Choice>
+    <mc:Fallback>
+      <p:transition spd="slow">
+        <p:fade/>
+      </p:transition>
+    </mc:Fallback>
+  </mc:AlternateContent>
   <p:clrMapOvr>
     <a:masterClrMapping/>
   </p:clrMapOvr>
@@ -12907,9 +12925,18 @@
       </p:sp>
     </p:spTree>
   </p:cSld>
-  <p:transition spd="med">
-    <p:split orient="horz" dir="out"/>
-  </p:transition>
+  <mc:AlternateContent xmlns:mc="http://schemas.openxmlformats.org/markup-compatibility/2006">
+    <mc:Choice xmlns:p14="http://schemas.microsoft.com/office/powerpoint/2010/main" xmlns:p159="http://schemas.microsoft.com/office/powerpoint/2015/09/main" Requires="p14">
+      <p:transition spd="slow" p14:dur="1400">
+        <p14:conveyor dir="l"/>
+      </p:transition>
+    </mc:Choice>
+    <mc:Fallback>
+      <p:transition spd="slow">
+        <p:push dir="l"/>
+      </p:transition>
+    </mc:Fallback>
+  </mc:AlternateContent>
   <p:clrMapOvr>
     <a:masterClrMapping/>
   </p:clrMapOvr>
@@ -14454,9 +14481,18 @@
       </p:sp>
     </p:spTree>
   </p:cSld>
-  <p:transition spd="slow">
-    <p:dissolve/>
-  </p:transition>
+  <mc:AlternateContent xmlns:mc="http://schemas.openxmlformats.org/markup-compatibility/2006">
+    <mc:Choice xmlns:p14="http://schemas.microsoft.com/office/powerpoint/2010/main" xmlns:p159="http://schemas.microsoft.com/office/powerpoint/2015/09/main" Requires="p14">
+      <p:transition spd="slow" p14:dur="1400">
+        <p14:prism/>
+      </p:transition>
+    </mc:Choice>
+    <mc:Fallback>
+      <p:transition spd="slow">
+        <p:dissolve/>
+      </p:transition>
+    </mc:Fallback>
+  </mc:AlternateContent>
   <p:clrMapOvr>
     <a:masterClrMapping/>
   </p:clrMapOvr>

</xml_diff>